<commit_message>
updated last time to 14
</commit_message>
<xml_diff>
--- a/docs/ecostats_lectures/lecture_14/14_01_lecture_powerpoint.pptx
+++ b/docs/ecostats_lectures/lecture_14/14_01_lecture_powerpoint.pptx
@@ -7505,7 +7505,7 @@
             </a:r>
             <a:r>
               <a:rPr/>
-              <a:t>) on islands in Gulf of California based on perimeter/area ratio. ::: {.panel column=“screen”}</a:t>
+              <a:t>) on islands in Gulf of California based on perimeter/area ratio.</a:t>
             </a:r>
           </a:p>
           <a:p>
@@ -7896,15 +7896,6 @@
                 <a:latin typeface="Courier"/>
               </a:rPr>
               <a:t>## Number of Fisher Scoring iterations: 6</a:t>
-            </a:r>
-          </a:p>
-          <a:p>
-            <a:pPr lvl="0" indent="0" marL="0">
-              <a:buNone/>
-            </a:pPr>
-            <a:r>
-              <a:rPr/>
-              <a:t>:::</a:t>
             </a:r>
           </a:p>
         </p:txBody>

</xml_diff>